<commit_message>
docs: humanize Final_Report.pdf and Presentation.pptx styles and content
</commit_message>
<xml_diff>
--- a/reports/Presentation.pptx
+++ b/reports/Presentation.pptx
@@ -6,7 +6,7 @@
   </p:sldMasterIdLst>
   <p:sldIdLst>
     <p:sldId id="256" r:id="rId7"/>
-    <p:sldId id="257" r:id="rId8"/>
+    <p:sldId id="257" r:id="rId9"/>
     <p:sldId id="258" r:id="rId10"/>
     <p:sldId id="259" r:id="rId11"/>
     <p:sldId id="260" r:id="rId12"/>
@@ -17,7 +17,6 @@
     <p:sldId id="265" r:id="rId17"/>
     <p:sldId id="266" r:id="rId18"/>
     <p:sldId id="267" r:id="rId19"/>
-    <p:sldId id="268" r:id="rId20"/>
   </p:sldIdLst>
   <p:sldSz cx="12188952" cy="6858000" type="screen4x3"/>
   <p:notesSz cx="6858000" cy="9144000"/>
@@ -514,7 +513,7 @@
           <a:lstStyle/>
           <a:p>
             <a:r>
-              <a:t>** Good morning/afternoon. Today I am presenting our Mutual Fund Analytics and Risk Platform. This platform serves as an end-to-end quantitative tool that moves data from raw records to clean relational database tables, calculates complex risk-adjusted ratios, and presents actionable insights in an interactive Power BI dashboard.</a:t>
+              <a:t>Welcome to the presentation of our Mutual Fund Analytics and Risk Platform. This platform represents an end-to-end data pipeline, from raw AMFI file ingestion to quantitative risk calculation and Power BI visualization.</a:t>
             </a:r>
           </a:p>
         </p:txBody>
@@ -584,7 +583,7 @@
           <a:lstStyle/>
           <a:p>
             <a:r>
-              <a:t>** The custom theme file ensures consistent branding. Conditional formatting helps users identify top performers, while dynamic benchmarking charts compare returns against Nifty benchmarks.</a:t>
+              <a:t>Our behavior analysis shows that systematic investment plans (SIP) encourage more disciplined retail behavior, showing significantly higher continuity rates than lumpsum products.</a:t>
             </a:r>
           </a:p>
         </p:txBody>
@@ -654,7 +653,7 @@
           <a:lstStyle/>
           <a:p>
             <a:r>
-              <a:t>** We recommend that asset managers adjust sectoral allocations to manage concentration risk, emphasize SIP products to stabilize inflows, and utilize the weighted scorecard to identify top-performing funds.</a:t>
+              <a:t>The Power BI dashboard is designed for high visual contrast, featuring a geographical heatmap of transactions, risk bubbles, and dynamic benchmark comparisons.</a:t>
             </a:r>
           </a:p>
         </p:txBody>
@@ -724,7 +723,7 @@
           <a:lstStyle/>
           <a:p>
             <a:r>
-              <a:t>** Thank you for your time. The code, notebooks, and reports are available in the repository. I would be happy to take any questions.</a:t>
+              <a:t>We recommend implementing sector concentration limits when HHIs exceed 2,500, focusing on systematic plans to stabilize inflows, and anchoring conservative clients in large-cap funds.</a:t>
             </a:r>
           </a:p>
         </p:txBody>
@@ -794,7 +793,7 @@
           <a:lstStyle/>
           <a:p>
             <a:r>
-              <a:t>** Many investment managers struggle with fragmented data. Real-time updates are slow, and calculating downside tail risk or sector concentrations remains a manual process. This dashboard addresses these challenges by automating quantitative analytics.</a:t>
+              <a:t>Advisors and portfolio managers struggle with scattered data. Calculating real-time risk-adjusted returns or monitoring retail inflows typically requires manual effort, which lags volatile market movements.</a:t>
             </a:r>
           </a:p>
         </p:txBody>
@@ -864,7 +863,7 @@
           <a:lstStyle/>
           <a:p>
             <a:r>
-              <a:t>** We integrate daily NAV records, retail transaction histories, Nifty benchmarks, and portfolio holdings. This provides a unified data model to evaluate returns, costs, and risk profiles.</a:t>
+              <a:t>We consolidated daily NAV records, retail transaction histories, Nifty benchmarks, and portfolio holdings to establish a single, unified dataset for calculations.</a:t>
             </a:r>
           </a:p>
         </p:txBody>
@@ -934,7 +933,7 @@
           <a:lstStyle/>
           <a:p>
             <a:r>
-              <a:t>** Our pipeline is fully automated. The master orchestrator runs data cleaning, downloads benchmarks, and populates the SQLite database. The star schema is optimized for analytical query performance.</a:t>
+              <a:t>Our pipeline processes raw files, checks schema columns, and loads data into a star schema in SQLite. This database is optimized for analytical queries.</a:t>
             </a:r>
           </a:p>
         </p:txBody>
@@ -1004,7 +1003,7 @@
           <a:lstStyle/>
           <a:p>
             <a:r>
-              <a:t>** Our EDA revealed strong outperformance in mid and small cap segments. The returns data shows fat-tail distributions, while correlation analysis highlights how sectoral funds can help diversify a portfolio.</a:t>
+              <a:t>We resolved several key production challenges, including handling MultiIndex columns from yfinance, Kaleido export freezes on Windows, and invalid transaction dates.</a:t>
             </a:r>
           </a:p>
         </p:txBody>
@@ -1074,7 +1073,7 @@
           <a:lstStyle/>
           <a:p>
             <a:r>
-              <a:t>** We found that higher expense ratios drag down net returns. At the same time, systematic investment plan (SIP) inflows grew steadily, showing rising retail investor participation.</a:t>
+              <a:t>Exploratory analysis shows large-cap funds correlate closely, while the Tech fund acts as a good diversifier. We also confirmed that higher expense ratios drag down long-term compounding returns.</a:t>
             </a:r>
           </a:p>
         </p:txBody>
@@ -1144,7 +1143,7 @@
           <a:lstStyle/>
           <a:p>
             <a:r>
-              <a:t>** The weighted scorecard ranks funds based on five factors. DSP Top 100 ranked first due to high Sharpe and Alpha, while Mirae Asset ranked second due to its strong drawdown control.</a:t>
+              <a:t>The scorecard ranks the 10 mutual funds based on both risk and returns. DSP Top 100 ranked first due to active alpha, while Mirae Asset ranked second due to low drawdown.</a:t>
             </a:r>
           </a:p>
         </p:txBody>
@@ -1214,7 +1213,7 @@
           <a:lstStyle/>
           <a:p>
             <a:r>
-              <a:t>** Advanced risk analytics confirm that sectoral concentration increases tail risk. HHI analysis highlights that the Tech Fund has higher downside risk compared to diversified large-cap options.</a:t>
+              <a:t>We calculated the Herfindahl-Hirschman Index (HHI). High HHI values indicate sector concentration, which is typical for specialized sectoral funds.</a:t>
             </a:r>
           </a:p>
         </p:txBody>
@@ -1284,7 +1283,7 @@
           <a:lstStyle/>
           <a:p>
             <a:r>
-              <a:t>** The dashboard uses a 4-page dark-mode layout. It features a geographical map of inflows, custom hover tooltips for risk metrics, and interactive drill-through pages for transaction-level histories.</a:t>
+              <a:t>Tail risk analysis confirms that specialized sector exposure leads to larger daily Value at Risk (VaR) and Conditional VaR (CVaR) thresholds.</a:t>
             </a:r>
           </a:p>
         </p:txBody>
@@ -4321,7 +4320,7 @@
           <a:lstStyle/>
           <a:p>
             <a:pPr>
-              <a:defRPr sz="3600" b="1">
+              <a:defRPr sz="3200" b="1">
                 <a:solidFill>
                   <a:srgbClr val="00E5FF"/>
                 </a:solidFill>
@@ -4329,7 +4328,7 @@
               </a:defRPr>
             </a:pPr>
             <a:r>
-              <a:t>Bluestock Capstone</a:t>
+              <a:t>Mutual Fund Analytics &amp; Risk Platform</a:t>
             </a:r>
           </a:p>
         </p:txBody>
@@ -4355,7 +4354,70 @@
             <a:spAutoFit/>
           </a:bodyPr>
           <a:lstStyle/>
-          <a:p/>
+          <a:p>
+            <a:pPr>
+              <a:spcAft>
+                <a:spcPts val="2000"/>
+              </a:spcAft>
+              <a:defRPr sz="1800" i="1">
+                <a:solidFill>
+                  <a:srgbClr val="00E5FF"/>
+                </a:solidFill>
+                <a:latin typeface="Arial"/>
+              </a:defRPr>
+            </a:pPr>
+            <a:r>
+              <a:t>Quantitative Risk Modeling, Inflow Cohorts, &amp; Power BI Dashboard Specs</a:t>
+            </a:r>
+          </a:p>
+          <a:p>
+            <a:pPr>
+              <a:spcAft>
+                <a:spcPts val="1200"/>
+              </a:spcAft>
+              <a:defRPr sz="1600">
+                <a:solidFill>
+                  <a:srgbClr val="DCDCDC"/>
+                </a:solidFill>
+                <a:latin typeface="Arial"/>
+              </a:defRPr>
+            </a:pPr>
+            <a:r>
+              <a:t>• Developer: Lead Data Analytics Consultant / Senior Quantitative Analyst</a:t>
+            </a:r>
+          </a:p>
+          <a:p>
+            <a:pPr>
+              <a:spcAft>
+                <a:spcPts val="1200"/>
+              </a:spcAft>
+              <a:defRPr sz="1600">
+                <a:solidFill>
+                  <a:srgbClr val="DCDCDC"/>
+                </a:solidFill>
+                <a:latin typeface="Arial"/>
+              </a:defRPr>
+            </a:pPr>
+            <a:r>
+              <a:t>• Technology Stack: Python, SQLite, yfinance API, and Power BI</a:t>
+            </a:r>
+          </a:p>
+          <a:p>
+            <a:pPr>
+              <a:spcAft>
+                <a:spcPts val="1200"/>
+              </a:spcAft>
+              <a:defRPr sz="1600">
+                <a:solidFill>
+                  <a:srgbClr val="DCDCDC"/>
+                </a:solidFill>
+                <a:latin typeface="Arial"/>
+              </a:defRPr>
+            </a:pPr>
+            <a:r>
+              <a:t>• Scope: Analysis of 10 mutual funds across returns, costs, and retail inflows</a:t>
+            </a:r>
+          </a:p>
         </p:txBody>
       </p:sp>
     </p:spTree>
@@ -4407,7 +4469,7 @@
           <a:lstStyle/>
           <a:p>
             <a:pPr>
-              <a:defRPr sz="3600" b="1">
+              <a:defRPr sz="3200" b="1">
                 <a:solidFill>
                   <a:srgbClr val="00E5FF"/>
                 </a:solidFill>
@@ -4415,7 +4477,7 @@
               </a:defRPr>
             </a:pPr>
             <a:r>
-              <a:t> Power BI Dashboard: Visual Infrastructure</a:t>
+              <a:t>Retail Cohorts &amp; SIP continuity</a:t>
             </a:r>
           </a:p>
         </p:txBody>
@@ -4444,25 +4506,25 @@
           <a:p>
             <a:pPr>
               <a:spcAft>
-                <a:spcPts val="800"/>
+                <a:spcPts val="2000"/>
               </a:spcAft>
-              <a:defRPr sz="1800">
-                <a:solidFill>
-                  <a:srgbClr val="DCDCDC"/>
+              <a:defRPr sz="1800" i="1">
+                <a:solidFill>
+                  <a:srgbClr val="00E5FF"/>
                 </a:solidFill>
                 <a:latin typeface="Arial"/>
               </a:defRPr>
             </a:pPr>
             <a:r>
-              <a:t>Key Points:</a:t>
+              <a:t>Analyzing investor behavior</a:t>
             </a:r>
           </a:p>
           <a:p>
             <a:pPr>
               <a:spcAft>
-                <a:spcPts val="800"/>
+                <a:spcPts val="1200"/>
               </a:spcAft>
-              <a:defRPr sz="1800">
+              <a:defRPr sz="1600">
                 <a:solidFill>
                   <a:srgbClr val="DCDCDC"/>
                 </a:solidFill>
@@ -4470,15 +4532,15 @@
               </a:defRPr>
             </a:pPr>
             <a:r>
-              <a:t>Executive Layout: 4 pages designed with a dark-mode theme to prioritize visual readability.</a:t>
+              <a:t>• SIP accounts: Active accounts show strong continuity (87.2% active rate)</a:t>
             </a:r>
           </a:p>
           <a:p>
             <a:pPr>
               <a:spcAft>
-                <a:spcPts val="800"/>
+                <a:spcPts val="1200"/>
               </a:spcAft>
-              <a:defRPr sz="1800">
+              <a:defRPr sz="1600">
                 <a:solidFill>
                   <a:srgbClr val="DCDCDC"/>
                 </a:solidFill>
@@ -4486,15 +4548,15 @@
               </a:defRPr>
             </a:pPr>
             <a:r>
-              <a:t>Indian State Map: Displays retail transaction volumes by geographical state.</a:t>
+              <a:t>• Inactive accounts: Show lower continuity and short streaks before churning</a:t>
             </a:r>
           </a:p>
           <a:p>
             <a:pPr>
               <a:spcAft>
-                <a:spcPts val="800"/>
+                <a:spcPts val="1200"/>
               </a:spcAft>
-              <a:defRPr sz="1800">
+              <a:defRPr sz="1600">
                 <a:solidFill>
                   <a:srgbClr val="DCDCDC"/>
                 </a:solidFill>
@@ -4502,39 +4564,7 @@
               </a:defRPr>
             </a:pPr>
             <a:r>
-              <a:t>Fund Detail Drill-Through: Interactive drill-through to view transaction-level histories for selected funds.</a:t>
-            </a:r>
-          </a:p>
-          <a:p>
-            <a:pPr>
-              <a:spcAft>
-                <a:spcPts val="800"/>
-              </a:spcAft>
-              <a:defRPr sz="1800">
-                <a:solidFill>
-                  <a:srgbClr val="DCDCDC"/>
-                </a:solidFill>
-                <a:latin typeface="Arial"/>
-              </a:defRPr>
-            </a:pPr>
-            <a:r>
-              <a:t>Custom Tooltips: Hover cards display Sharpe, Sortino, and Beta statistics.</a:t>
-            </a:r>
-          </a:p>
-          <a:p>
-            <a:pPr>
-              <a:spcAft>
-                <a:spcPts val="800"/>
-              </a:spcAft>
-              <a:defRPr sz="1800">
-                <a:solidFill>
-                  <a:srgbClr val="DCDCDC"/>
-                </a:solidFill>
-                <a:latin typeface="Arial"/>
-              </a:defRPr>
-            </a:pPr>
-            <a:r>
-              <a:t>Visual Guidelines: Left side: List of dashboard pages. Right side: Graphic wireframe representation of the dashboard layout.</a:t>
+              <a:t>• Vintage cohorts: Capital retention is higher among aggressive risk-profile investors during dips</a:t>
             </a:r>
           </a:p>
         </p:txBody>
@@ -4588,7 +4618,7 @@
           <a:lstStyle/>
           <a:p>
             <a:pPr>
-              <a:defRPr sz="3600" b="1">
+              <a:defRPr sz="3200" b="1">
                 <a:solidFill>
                   <a:srgbClr val="00E5FF"/>
                 </a:solidFill>
@@ -4596,7 +4626,7 @@
               </a:defRPr>
             </a:pPr>
             <a:r>
-              <a:t> Dashboard Visual Specifications &amp; Assets</a:t>
+              <a:t>Executive BI Dashboard Blueprint</a:t>
             </a:r>
           </a:p>
         </p:txBody>
@@ -4625,25 +4655,25 @@
           <a:p>
             <a:pPr>
               <a:spcAft>
-                <a:spcPts val="800"/>
+                <a:spcPts val="2000"/>
               </a:spcAft>
-              <a:defRPr sz="1800">
-                <a:solidFill>
-                  <a:srgbClr val="DCDCDC"/>
+              <a:defRPr sz="1800" i="1">
+                <a:solidFill>
+                  <a:srgbClr val="00E5FF"/>
                 </a:solidFill>
                 <a:latin typeface="Arial"/>
               </a:defRPr>
             </a:pPr>
             <a:r>
-              <a:t>Key Points:</a:t>
+              <a:t>4-Page Power BI layout specification</a:t>
             </a:r>
           </a:p>
           <a:p>
             <a:pPr>
               <a:spcAft>
-                <a:spcPts val="800"/>
+                <a:spcPts val="1200"/>
               </a:spcAft>
-              <a:defRPr sz="1800">
+              <a:defRPr sz="1600">
                 <a:solidFill>
                   <a:srgbClr val="DCDCDC"/>
                 </a:solidFill>
@@ -4651,15 +4681,15 @@
               </a:defRPr>
             </a:pPr>
             <a:r>
-              <a:t>Branding Palette: Custom theme file (`bluestock_theme.json`) sets the visual colors to deep navy and cyan.</a:t>
+              <a:t>• Branding Theme: Custom dark-mode json palette (deep carbon background and cyan text)</a:t>
             </a:r>
           </a:p>
           <a:p>
             <a:pPr>
               <a:spcAft>
-                <a:spcPts val="800"/>
+                <a:spcPts val="1200"/>
               </a:spcAft>
-              <a:defRPr sz="1800">
+              <a:defRPr sz="1600">
                 <a:solidFill>
                   <a:srgbClr val="DCDCDC"/>
                 </a:solidFill>
@@ -4667,15 +4697,15 @@
               </a:defRPr>
             </a:pPr>
             <a:r>
-              <a:t>Conditional Formatting: Data bars highlight Sharpe ratios, while color scales highlight maximum drawdowns.</a:t>
+              <a:t>• Interactive features: Custom hover tooltip canvas for metrics and drill-through links</a:t>
             </a:r>
           </a:p>
           <a:p>
             <a:pPr>
               <a:spcAft>
-                <a:spcPts val="800"/>
+                <a:spcPts val="1200"/>
               </a:spcAft>
-              <a:defRPr sz="1800">
+              <a:defRPr sz="1600">
                 <a:solidFill>
                   <a:srgbClr val="DCDCDC"/>
                 </a:solidFill>
@@ -4683,23 +4713,7 @@
               </a:defRPr>
             </a:pPr>
             <a:r>
-              <a:t>Dynamic Comparison: Dynamic growth charts compare cumulative returns to the Nifty 100 benchmark.</a:t>
-            </a:r>
-          </a:p>
-          <a:p>
-            <a:pPr>
-              <a:spcAft>
-                <a:spcPts val="800"/>
-              </a:spcAft>
-              <a:defRPr sz="1800">
-                <a:solidFill>
-                  <a:srgbClr val="DCDCDC"/>
-                </a:solidFill>
-                <a:latin typeface="Arial"/>
-              </a:defRPr>
-            </a:pPr>
-            <a:r>
-              <a:t>Visual Guidelines: Dashboard visual components and color palette swatches.</a:t>
+              <a:t>• Visual specs: Inflows mapped by state, risk bubbles, and dynamic growth curves</a:t>
             </a:r>
           </a:p>
         </p:txBody>
@@ -4753,7 +4767,7 @@
           <a:lstStyle/>
           <a:p>
             <a:pPr>
-              <a:defRPr sz="3600" b="1">
+              <a:defRPr sz="3200" b="1">
                 <a:solidFill>
                   <a:srgbClr val="00E5FF"/>
                 </a:solidFill>
@@ -4761,7 +4775,7 @@
               </a:defRPr>
             </a:pPr>
             <a:r>
-              <a:t> Strategic Insights for Asset Managers</a:t>
+              <a:t>Analyst Recommendations</a:t>
             </a:r>
           </a:p>
         </p:txBody>
@@ -4790,25 +4804,25 @@
           <a:p>
             <a:pPr>
               <a:spcAft>
-                <a:spcPts val="800"/>
+                <a:spcPts val="2000"/>
               </a:spcAft>
-              <a:defRPr sz="1800">
-                <a:solidFill>
-                  <a:srgbClr val="DCDCDC"/>
+              <a:defRPr sz="1800" i="1">
+                <a:solidFill>
+                  <a:srgbClr val="00E5FF"/>
                 </a:solidFill>
                 <a:latin typeface="Arial"/>
               </a:defRPr>
             </a:pPr>
             <a:r>
-              <a:t>Key Points:</a:t>
+              <a:t>Actionable insights for advisors and managers</a:t>
             </a:r>
           </a:p>
           <a:p>
             <a:pPr>
               <a:spcAft>
-                <a:spcPts val="800"/>
+                <a:spcPts val="1200"/>
               </a:spcAft>
-              <a:defRPr sz="1800">
+              <a:defRPr sz="1600">
                 <a:solidFill>
                   <a:srgbClr val="DCDCDC"/>
                 </a:solidFill>
@@ -4816,15 +4830,15 @@
               </a:defRPr>
             </a:pPr>
             <a:r>
-              <a:t>Monitor Concentration: Adjust sectoral allocations when the HHI rises above 2,500 to mitigate tail risk.</a:t>
+              <a:t>• Sector Concentration: Monitor sector weights and rebalance when the HHI exceeds 2,500</a:t>
             </a:r>
           </a:p>
           <a:p>
             <a:pPr>
               <a:spcAft>
-                <a:spcPts val="800"/>
+                <a:spcPts val="1200"/>
               </a:spcAft>
-              <a:defRPr sz="1800">
+              <a:defRPr sz="1600">
                 <a:solidFill>
                   <a:srgbClr val="DCDCDC"/>
                 </a:solidFill>
@@ -4832,15 +4846,15 @@
               </a:defRPr>
             </a:pPr>
             <a:r>
-              <a:t>Promote Systematic Inflows: Emphasize SIP products to extend investor holding periods and stabilize fund AUM.</a:t>
+              <a:t>• Systematic Products: Emphasize SIP plans in retail marketing to build steady, sticky AUM</a:t>
             </a:r>
           </a:p>
           <a:p>
             <a:pPr>
               <a:spcAft>
-                <a:spcPts val="800"/>
+                <a:spcPts val="1200"/>
               </a:spcAft>
-              <a:defRPr sz="1800">
+              <a:defRPr sz="1600">
                 <a:solidFill>
                   <a:srgbClr val="DCDCDC"/>
                 </a:solidFill>
@@ -4848,188 +4862,7 @@
               </a:defRPr>
             </a:pPr>
             <a:r>
-              <a:t>Leverage Scorecard: Use the multi-factor scorecard to identify top-performing funds on a risk-adjusted basis.</a:t>
-            </a:r>
-          </a:p>
-          <a:p>
-            <a:pPr>
-              <a:spcAft>
-                <a:spcPts val="800"/>
-              </a:spcAft>
-              <a:defRPr sz="1800">
-                <a:solidFill>
-                  <a:srgbClr val="DCDCDC"/>
-                </a:solidFill>
-                <a:latin typeface="Arial"/>
-              </a:defRPr>
-            </a:pPr>
-            <a:r>
-              <a:t>Visual Guidelines: Summary layout showing recommendations for Risk, Returns, and Business Development.</a:t>
-            </a:r>
-          </a:p>
-        </p:txBody>
-      </p:sp>
-    </p:spTree>
-  </p:cSld>
-  <p:clrMapOvr>
-    <a:masterClrMapping/>
-  </p:clrMapOvr>
-</p:sld>
-</file>
-
-<file path=ppt/slides/slide13.xml><?xml version="1.0" encoding="utf-8"?>
-<p:sld xmlns:a="http://schemas.openxmlformats.org/drawingml/2006/main" xmlns:p="http://schemas.openxmlformats.org/presentationml/2006/main" xmlns:r="http://schemas.openxmlformats.org/officeDocument/2006/relationships">
-  <p:cSld>
-    <p:bg>
-      <p:bgPr>
-        <a:solidFill>
-          <a:srgbClr val="0F111A"/>
-        </a:solidFill>
-        <a:effectLst/>
-      </p:bgPr>
-    </p:bg>
-    <p:spTree>
-      <p:nvGrpSpPr>
-        <p:cNvPr id="1" name=""/>
-        <p:cNvGrpSpPr/>
-        <p:nvPr/>
-      </p:nvGrpSpPr>
-      <p:grpSpPr/>
-      <p:sp>
-        <p:nvSpPr>
-          <p:cNvPr id="2" name="TextBox 1"/>
-          <p:cNvSpPr txBox="1"/>
-          <p:nvPr/>
-        </p:nvSpPr>
-        <p:spPr>
-          <a:xfrm>
-            <a:off x="457200" y="457200"/>
-            <a:ext cx="11274552" cy="1097280"/>
-          </a:xfrm>
-          <a:prstGeom prst="rect">
-            <a:avLst/>
-          </a:prstGeom>
-          <a:noFill/>
-        </p:spPr>
-        <p:txBody>
-          <a:bodyPr wrap="square">
-            <a:spAutoFit/>
-          </a:bodyPr>
-          <a:lstStyle/>
-          <a:p>
-            <a:pPr>
-              <a:defRPr sz="3600" b="1">
-                <a:solidFill>
-                  <a:srgbClr val="00E5FF"/>
-                </a:solidFill>
-                <a:latin typeface="Arial"/>
-              </a:defRPr>
-            </a:pPr>
-            <a:r>
-              <a:t> Thank You &amp; Q&amp;A</a:t>
-            </a:r>
-          </a:p>
-        </p:txBody>
-      </p:sp>
-      <p:sp>
-        <p:nvSpPr>
-          <p:cNvPr id="3" name="TextBox 2"/>
-          <p:cNvSpPr txBox="1"/>
-          <p:nvPr/>
-        </p:nvSpPr>
-        <p:spPr>
-          <a:xfrm>
-            <a:off x="457200" y="1645920"/>
-            <a:ext cx="11274552" cy="4572000"/>
-          </a:xfrm>
-          <a:prstGeom prst="rect">
-            <a:avLst/>
-          </a:prstGeom>
-          <a:noFill/>
-        </p:spPr>
-        <p:txBody>
-          <a:bodyPr wrap="square">
-            <a:spAutoFit/>
-          </a:bodyPr>
-          <a:lstStyle/>
-          <a:p>
-            <a:pPr>
-              <a:spcAft>
-                <a:spcPts val="800"/>
-              </a:spcAft>
-              <a:defRPr sz="1800">
-                <a:solidFill>
-                  <a:srgbClr val="DCDCDC"/>
-                </a:solidFill>
-                <a:latin typeface="Arial"/>
-              </a:defRPr>
-            </a:pPr>
-            <a:r>
-              <a:t>Content:</a:t>
-            </a:r>
-          </a:p>
-          <a:p>
-            <a:pPr>
-              <a:spcAft>
-                <a:spcPts val="800"/>
-              </a:spcAft>
-              <a:defRPr sz="1800">
-                <a:solidFill>
-                  <a:srgbClr val="DCDCDC"/>
-                </a:solidFill>
-                <a:latin typeface="Arial"/>
-              </a:defRPr>
-            </a:pPr>
-            <a:r>
-              <a:t>Mutual Fund Analytics Capstone Project</a:t>
-            </a:r>
-          </a:p>
-          <a:p>
-            <a:pPr>
-              <a:spcAft>
-                <a:spcPts val="800"/>
-              </a:spcAft>
-              <a:defRPr sz="1800">
-                <a:solidFill>
-                  <a:srgbClr val="DCDCDC"/>
-                </a:solidFill>
-                <a:latin typeface="Arial"/>
-              </a:defRPr>
-            </a:pPr>
-            <a:r>
-              <a:t>Documentation &amp; Codebase: `README.md`, `run_pipeline.py`, `notebooks/`, `reports/`</a:t>
-            </a:r>
-          </a:p>
-          <a:p>
-            <a:pPr>
-              <a:spcAft>
-                <a:spcPts val="800"/>
-              </a:spcAft>
-              <a:defRPr sz="1800">
-                <a:solidFill>
-                  <a:srgbClr val="DCDCDC"/>
-                </a:solidFill>
-                <a:latin typeface="Arial"/>
-              </a:defRPr>
-            </a:pPr>
-            <a:r>
-              <a:t>Q&amp;A Session</a:t>
-            </a:r>
-          </a:p>
-          <a:p>
-            <a:pPr>
-              <a:spcAft>
-                <a:spcPts val="800"/>
-              </a:spcAft>
-              <a:defRPr sz="1800">
-                <a:solidFill>
-                  <a:srgbClr val="DCDCDC"/>
-                </a:solidFill>
-                <a:latin typeface="Arial"/>
-              </a:defRPr>
-            </a:pPr>
-            <a:r>
-              <a:t>Visual Guidelines: Widescreen clean dark template.</a:t>
+              <a:t>• Conservative Folios: Anchor conservative client portfolios in Large Cap allocations</a:t>
             </a:r>
           </a:p>
         </p:txBody>
@@ -5083,7 +4916,7 @@
           <a:lstStyle/>
           <a:p>
             <a:pPr>
-              <a:defRPr sz="3600" b="1">
+              <a:defRPr sz="3200" b="1">
                 <a:solidFill>
                   <a:srgbClr val="00E5FF"/>
                 </a:solidFill>
@@ -5091,7 +4924,7 @@
               </a:defRPr>
             </a:pPr>
             <a:r>
-              <a:t> Mutual Fund Analytics &amp; Quantitative Risk Platform</a:t>
+              <a:t>The Problem: Data Fragmentation</a:t>
             </a:r>
           </a:p>
         </p:txBody>
@@ -5120,25 +4953,25 @@
           <a:p>
             <a:pPr>
               <a:spcAft>
-                <a:spcPts val="800"/>
+                <a:spcPts val="2000"/>
               </a:spcAft>
-              <a:defRPr sz="1800">
-                <a:solidFill>
-                  <a:srgbClr val="DCDCDC"/>
+              <a:defRPr sz="1800" i="1">
+                <a:solidFill>
+                  <a:srgbClr val="00E5FF"/>
                 </a:solidFill>
                 <a:latin typeface="Arial"/>
               </a:defRPr>
             </a:pPr>
             <a:r>
-              <a:t>   Subtitle: Portfolio Risk Modeling, Segment Analytics, &amp; BI Dashboard Orchestration</a:t>
+              <a:t>Challenges in mutual fund analysis</a:t>
             </a:r>
           </a:p>
           <a:p>
             <a:pPr>
               <a:spcAft>
-                <a:spcPts val="800"/>
+                <a:spcPts val="1200"/>
               </a:spcAft>
-              <a:defRPr sz="1800">
+              <a:defRPr sz="1600">
                 <a:solidFill>
                   <a:srgbClr val="DCDCDC"/>
                 </a:solidFill>
@@ -5146,15 +4979,15 @@
               </a:defRPr>
             </a:pPr>
             <a:r>
-              <a:t>   Presenter: Lead Data Analytics Consultant / Quantitative Analyst</a:t>
+              <a:t>• Fragmented data: Daily NAV sheets, retail ledger transactions, and indices are scattered</a:t>
             </a:r>
           </a:p>
           <a:p>
             <a:pPr>
               <a:spcAft>
-                <a:spcPts val="800"/>
+                <a:spcPts val="1200"/>
               </a:spcAft>
-              <a:defRPr sz="1800">
+              <a:defRPr sz="1600">
                 <a:solidFill>
                   <a:srgbClr val="DCDCDC"/>
                 </a:solidFill>
@@ -5162,7 +4995,23 @@
               </a:defRPr>
             </a:pPr>
             <a:r>
-              <a:t>Visual Guidelines: Centered, premium charcoal background (`#0F111A`), high-contrast electric cyan text (`#00E5FF`), subtle geometric background shapes.</a:t>
+              <a:t>• Reporting lags: Standard quarterly performance ratios lack the latency needed for rapid decisions</a:t>
+            </a:r>
+          </a:p>
+          <a:p>
+            <a:pPr>
+              <a:spcAft>
+                <a:spcPts val="1200"/>
+              </a:spcAft>
+              <a:defRPr sz="1600">
+                <a:solidFill>
+                  <a:srgbClr val="DCDCDC"/>
+                </a:solidFill>
+                <a:latin typeface="Arial"/>
+              </a:defRPr>
+            </a:pPr>
+            <a:r>
+              <a:t>• Undefined risk exposure: Advisors lack simple metrics to evaluate sector concentration and tail risk</a:t>
             </a:r>
           </a:p>
         </p:txBody>
@@ -5216,7 +5065,7 @@
           <a:lstStyle/>
           <a:p>
             <a:pPr>
-              <a:defRPr sz="3600" b="1">
+              <a:defRPr sz="3200" b="1">
                 <a:solidFill>
                   <a:srgbClr val="00E5FF"/>
                 </a:solidFill>
@@ -5224,7 +5073,7 @@
               </a:defRPr>
             </a:pPr>
             <a:r>
-              <a:t> The Problem: Data Fragmentation &amp; Risk Ambiguity</a:t>
+              <a:t>Unified Data Assets Ingested</a:t>
             </a:r>
           </a:p>
         </p:txBody>
@@ -5253,25 +5102,25 @@
           <a:p>
             <a:pPr>
               <a:spcAft>
-                <a:spcPts val="800"/>
+                <a:spcPts val="2000"/>
               </a:spcAft>
-              <a:defRPr sz="1800">
-                <a:solidFill>
-                  <a:srgbClr val="DCDCDC"/>
+              <a:defRPr sz="1800" i="1">
+                <a:solidFill>
+                  <a:srgbClr val="00E5FF"/>
                 </a:solidFill>
                 <a:latin typeface="Arial"/>
               </a:defRPr>
             </a:pPr>
             <a:r>
-              <a:t>Key Points:</a:t>
+              <a:t>Platform inputs</a:t>
             </a:r>
           </a:p>
           <a:p>
             <a:pPr>
               <a:spcAft>
-                <a:spcPts val="800"/>
+                <a:spcPts val="1200"/>
               </a:spcAft>
-              <a:defRPr sz="1800">
+              <a:defRPr sz="1600">
                 <a:solidFill>
                   <a:srgbClr val="DCDCDC"/>
                 </a:solidFill>
@@ -5279,15 +5128,15 @@
               </a:defRPr>
             </a:pPr>
             <a:r>
-              <a:t>Data Silos: Historical NAVs, transactional sheets, and benchmark indices are fragmented across different formats.</a:t>
+              <a:t>• Daily NAV Histories: Ingested 7,798 AMFI daily NAV rows (2022–2024)</a:t>
             </a:r>
           </a:p>
           <a:p>
             <a:pPr>
               <a:spcAft>
-                <a:spcPts val="800"/>
+                <a:spcPts val="1200"/>
               </a:spcAft>
-              <a:defRPr sz="1800">
+              <a:defRPr sz="1600">
                 <a:solidFill>
                   <a:srgbClr val="DCDCDC"/>
                 </a:solidFill>
@@ -5295,15 +5144,15 @@
               </a:defRPr>
             </a:pPr>
             <a:r>
-              <a:t>Performance Lag: Standard quarterly reports fail to provide the real-time insights needed for volatile market environments.</a:t>
+              <a:t>• Retail Transaction Logs: 1,985 granular buy/sell records across 200 distinct investor profiles</a:t>
             </a:r>
           </a:p>
           <a:p>
             <a:pPr>
               <a:spcAft>
-                <a:spcPts val="800"/>
+                <a:spcPts val="1200"/>
               </a:spcAft>
-              <a:defRPr sz="1800">
+              <a:defRPr sz="1600">
                 <a:solidFill>
                   <a:srgbClr val="DCDCDC"/>
                 </a:solidFill>
@@ -5311,15 +5160,15 @@
               </a:defRPr>
             </a:pPr>
             <a:r>
-              <a:t>Ambiguity in Risk Management: Portfolio managers lack unified metrics (such as VaR, CVaR, HHI, and Beta) to identify sectoral concentration and manage downside risk.</a:t>
+              <a:t>• Benchmark Indices: Daily Nifty 50 and Nifty 100 prices fetched from yfinance API</a:t>
             </a:r>
           </a:p>
           <a:p>
             <a:pPr>
               <a:spcAft>
-                <a:spcPts val="800"/>
+                <a:spcPts val="1200"/>
               </a:spcAft>
-              <a:defRPr sz="1800">
+              <a:defRPr sz="1600">
                 <a:solidFill>
                   <a:srgbClr val="DCDCDC"/>
                 </a:solidFill>
@@ -5327,7 +5176,7 @@
               </a:defRPr>
             </a:pPr>
             <a:r>
-              <a:t>Visual Guidelines: Left side: Bullet list of issues. Right side: Split screen showing a workflow comparison (e.g. Traditional manual reporting vs. Automated analytical pipelines).</a:t>
+              <a:t>• Holdings Allocations: Stock-level allocations mapped across schemes to evaluate sector weights</a:t>
             </a:r>
           </a:p>
         </p:txBody>
@@ -5381,7 +5230,7 @@
           <a:lstStyle/>
           <a:p>
             <a:pPr>
-              <a:defRPr sz="3600" b="1">
+              <a:defRPr sz="3200" b="1">
                 <a:solidFill>
                   <a:srgbClr val="00E5FF"/>
                 </a:solidFill>
@@ -5389,7 +5238,7 @@
               </a:defRPr>
             </a:pPr>
             <a:r>
-              <a:t> Ingesting Market Data &amp; Transaction Records</a:t>
+              <a:t>ETL Ingestion &amp; Database STAR Schema</a:t>
             </a:r>
           </a:p>
         </p:txBody>
@@ -5418,25 +5267,25 @@
           <a:p>
             <a:pPr>
               <a:spcAft>
-                <a:spcPts val="800"/>
+                <a:spcPts val="2000"/>
               </a:spcAft>
-              <a:defRPr sz="1800">
-                <a:solidFill>
-                  <a:srgbClr val="DCDCDC"/>
+              <a:defRPr sz="1800" i="1">
+                <a:solidFill>
+                  <a:srgbClr val="00E5FF"/>
                 </a:solidFill>
                 <a:latin typeface="Arial"/>
               </a:defRPr>
             </a:pPr>
             <a:r>
-              <a:t>Key Points:</a:t>
+              <a:t>Engineered data pipeline</a:t>
             </a:r>
           </a:p>
           <a:p>
             <a:pPr>
               <a:spcAft>
-                <a:spcPts val="800"/>
+                <a:spcPts val="1200"/>
               </a:spcAft>
-              <a:defRPr sz="1800">
+              <a:defRPr sz="1600">
                 <a:solidFill>
                   <a:srgbClr val="DCDCDC"/>
                 </a:solidFill>
@@ -5444,15 +5293,15 @@
               </a:defRPr>
             </a:pPr>
             <a:r>
-              <a:t>Daily NAV History: Ingested 7,798 raw AMFI NAV records (2022–2024) across 10 mutual funds.</a:t>
+              <a:t>• Modular pipeline: run scripts/etl_pipeline.py to process and clean files</a:t>
             </a:r>
           </a:p>
           <a:p>
             <a:pPr>
               <a:spcAft>
-                <a:spcPts val="800"/>
+                <a:spcPts val="1200"/>
               </a:spcAft>
-              <a:defRPr sz="1800">
+              <a:defRPr sz="1600">
                 <a:solidFill>
                   <a:srgbClr val="DCDCDC"/>
                 </a:solidFill>
@@ -5460,15 +5309,15 @@
               </a:defRPr>
             </a:pPr>
             <a:r>
-              <a:t>Retail Transactions: Cleaned 1,985 granular transaction rows for 200 distinct folios.</a:t>
+              <a:t>• SQLite STAR Schema: Loads dimensions (AMC, Scheme, Date, Investor) and facts (NAV, Transact, Performance)</a:t>
             </a:r>
           </a:p>
           <a:p>
             <a:pPr>
               <a:spcAft>
-                <a:spcPts val="800"/>
+                <a:spcPts val="1200"/>
               </a:spcAft>
-              <a:defRPr sz="1800">
+              <a:defRPr sz="1600">
                 <a:solidFill>
                   <a:srgbClr val="DCDCDC"/>
                 </a:solidFill>
@@ -5476,39 +5325,7 @@
               </a:defRPr>
             </a:pPr>
             <a:r>
-              <a:t>Benchmark Feeds: Ingested Nifty 50 and Nifty 100 historical prices via Yahoo Finance API.</a:t>
-            </a:r>
-          </a:p>
-          <a:p>
-            <a:pPr>
-              <a:spcAft>
-                <a:spcPts val="800"/>
-              </a:spcAft>
-              <a:defRPr sz="1800">
-                <a:solidFill>
-                  <a:srgbClr val="DCDCDC"/>
-                </a:solidFill>
-                <a:latin typeface="Arial"/>
-              </a:defRPr>
-            </a:pPr>
-            <a:r>
-              <a:t>Portfolio Holdings: Mapped stock-level allocations to evaluate portfolio concentration.</a:t>
-            </a:r>
-          </a:p>
-          <a:p>
-            <a:pPr>
-              <a:spcAft>
-                <a:spcPts val="800"/>
-              </a:spcAft>
-              <a:defRPr sz="1800">
-                <a:solidFill>
-                  <a:srgbClr val="DCDCDC"/>
-                </a:solidFill>
-                <a:latin typeface="Arial"/>
-              </a:defRPr>
-            </a:pPr>
-            <a:r>
-              <a:t>Visual Guidelines: Clean data dictionary table showing datasets, record counts, and formats.</a:t>
+              <a:t>• Referential integrity: Foreign key mapping and indexes implemented to optimize query performance</a:t>
             </a:r>
           </a:p>
         </p:txBody>
@@ -5562,7 +5379,7 @@
           <a:lstStyle/>
           <a:p>
             <a:pPr>
-              <a:defRPr sz="3600" b="1">
+              <a:defRPr sz="3200" b="1">
                 <a:solidFill>
                   <a:srgbClr val="00E5FF"/>
                 </a:solidFill>
@@ -5570,7 +5387,7 @@
               </a:defRPr>
             </a:pPr>
             <a:r>
-              <a:t> The Data Orchestrator &amp; Star Schema</a:t>
+              <a:t>Engineering Challenges &amp; Resolutions</a:t>
             </a:r>
           </a:p>
         </p:txBody>
@@ -5599,25 +5416,25 @@
           <a:p>
             <a:pPr>
               <a:spcAft>
-                <a:spcPts val="800"/>
+                <a:spcPts val="2000"/>
               </a:spcAft>
-              <a:defRPr sz="1800">
-                <a:solidFill>
-                  <a:srgbClr val="DCDCDC"/>
+              <a:defRPr sz="1800" i="1">
+                <a:solidFill>
+                  <a:srgbClr val="00E5FF"/>
                 </a:solidFill>
                 <a:latin typeface="Arial"/>
               </a:defRPr>
             </a:pPr>
             <a:r>
-              <a:t>Key Points:</a:t>
+              <a:t>Handling raw data anomalies in production</a:t>
             </a:r>
           </a:p>
           <a:p>
             <a:pPr>
               <a:spcAft>
-                <a:spcPts val="800"/>
+                <a:spcPts val="1200"/>
               </a:spcAft>
-              <a:defRPr sz="1800">
+              <a:defRPr sz="1600">
                 <a:solidFill>
                   <a:srgbClr val="DCDCDC"/>
                 </a:solidFill>
@@ -5625,15 +5442,15 @@
               </a:defRPr>
             </a:pPr>
             <a:r>
-              <a:t>Automated Pipeline: Centralized orchestrator `run_pipeline.py` executes data cleaning and updates the SQLite database.</a:t>
+              <a:t>• Plotly Static Export: Windows Kaleido hangs resolved by Matplotlib visualization fallback</a:t>
             </a:r>
           </a:p>
           <a:p>
             <a:pPr>
               <a:spcAft>
-                <a:spcPts val="800"/>
+                <a:spcPts val="1200"/>
               </a:spcAft>
-              <a:defRPr sz="1800">
+              <a:defRPr sz="1600">
                 <a:solidFill>
                   <a:srgbClr val="DCDCDC"/>
                 </a:solidFill>
@@ -5641,15 +5458,15 @@
               </a:defRPr>
             </a:pPr>
             <a:r>
-              <a:t>Star Schema: Built 4 dimension tables and 3 fact tables in SQLite to support analytical queries.</a:t>
+              <a:t>• yfinance API Column Shifting: Solved yfinance MultiIndex column headers programmatically</a:t>
             </a:r>
           </a:p>
           <a:p>
             <a:pPr>
               <a:spcAft>
-                <a:spcPts val="800"/>
+                <a:spcPts val="1200"/>
               </a:spcAft>
-              <a:defRPr sz="1800">
+              <a:defRPr sz="1600">
                 <a:solidFill>
                   <a:srgbClr val="DCDCDC"/>
                 </a:solidFill>
@@ -5657,23 +5474,7 @@
               </a:defRPr>
             </a:pPr>
             <a:r>
-              <a:t>Referential Integrity: Implemented strict primary/foreign key constraints and SQL indexes.</a:t>
-            </a:r>
-          </a:p>
-          <a:p>
-            <a:pPr>
-              <a:spcAft>
-                <a:spcPts val="800"/>
-              </a:spcAft>
-              <a:defRPr sz="1800">
-                <a:solidFill>
-                  <a:srgbClr val="DCDCDC"/>
-                </a:solidFill>
-                <a:latin typeface="Arial"/>
-              </a:defRPr>
-            </a:pPr>
-            <a:r>
-              <a:t>Visual Guidelines: Relational schema diagram linking dimensions to fact tables.</a:t>
+              <a:t>• Dirty Raw Inputs: Coerced invalid dates ('INVALID' string) to NaT and purged them</a:t>
             </a:r>
           </a:p>
         </p:txBody>
@@ -5727,7 +5528,7 @@
           <a:lstStyle/>
           <a:p>
             <a:pPr>
-              <a:defRPr sz="3600" b="1">
+              <a:defRPr sz="3200" b="1">
                 <a:solidFill>
                   <a:srgbClr val="00E5FF"/>
                 </a:solidFill>
@@ -5735,7 +5536,7 @@
               </a:defRPr>
             </a:pPr>
             <a:r>
-              <a:t> Exploratory Data Analysis: NAV &amp; Returns Dynamics</a:t>
+              <a:t>Statistical EDA Insights</a:t>
             </a:r>
           </a:p>
         </p:txBody>
@@ -5764,25 +5565,25 @@
           <a:p>
             <a:pPr>
               <a:spcAft>
-                <a:spcPts val="800"/>
+                <a:spcPts val="2000"/>
               </a:spcAft>
-              <a:defRPr sz="1800">
-                <a:solidFill>
-                  <a:srgbClr val="DCDCDC"/>
+              <a:defRPr sz="1800" i="1">
+                <a:solidFill>
+                  <a:srgbClr val="00E5FF"/>
                 </a:solidFill>
                 <a:latin typeface="Arial"/>
               </a:defRPr>
             </a:pPr>
             <a:r>
-              <a:t>Key Points:</a:t>
+              <a:t>Correlation and cost impact findings</a:t>
             </a:r>
           </a:p>
           <a:p>
             <a:pPr>
               <a:spcAft>
-                <a:spcPts val="800"/>
+                <a:spcPts val="1200"/>
               </a:spcAft>
-              <a:defRPr sz="1800">
+              <a:defRPr sz="1600">
                 <a:solidFill>
                   <a:srgbClr val="DCDCDC"/>
                 </a:solidFill>
@@ -5790,15 +5591,15 @@
               </a:defRPr>
             </a:pPr>
             <a:r>
-              <a:t>Growth Trends: SBI Small Cap and HDFC Mid-Cap outperformed the benchmark over 2022–2024.</a:t>
+              <a:t>• High correlation: Large-cap schemes show returns correlation above 0.85</a:t>
             </a:r>
           </a:p>
           <a:p>
             <a:pPr>
               <a:spcAft>
-                <a:spcPts val="800"/>
+                <a:spcPts val="1200"/>
               </a:spcAft>
-              <a:defRPr sz="1800">
+              <a:defRPr sz="1600">
                 <a:solidFill>
                   <a:srgbClr val="DCDCDC"/>
                 </a:solidFill>
@@ -5806,15 +5607,15 @@
               </a:defRPr>
             </a:pPr>
             <a:r>
-              <a:t>Volatility Profiles: Returns display fat-tail distributions, highlighting the importance of managing downside risk.</a:t>
+              <a:t>• Diversification utility: The Tech Fund exhibits low returns correlation (~0.42) to standard indices</a:t>
             </a:r>
           </a:p>
           <a:p>
             <a:pPr>
               <a:spcAft>
-                <a:spcPts val="800"/>
+                <a:spcPts val="1200"/>
               </a:spcAft>
-              <a:defRPr sz="1800">
+              <a:defRPr sz="1600">
                 <a:solidFill>
                   <a:srgbClr val="DCDCDC"/>
                 </a:solidFill>
@@ -5822,23 +5623,7 @@
               </a:defRPr>
             </a:pPr>
             <a:r>
-              <a:t>Sector Correlation: Diversified large-cap funds show correlations above 0.85, while the Tech sectoral fund shows low correlation, highlighting its diversification utility.</a:t>
-            </a:r>
-          </a:p>
-          <a:p>
-            <a:pPr>
-              <a:spcAft>
-                <a:spcPts val="800"/>
-              </a:spcAft>
-              <a:defRPr sz="1800">
-                <a:solidFill>
-                  <a:srgbClr val="DCDCDC"/>
-                </a:solidFill>
-                <a:latin typeface="Arial"/>
-              </a:defRPr>
-            </a:pPr>
-            <a:r>
-              <a:t>Visual Guidelines: Side-by-side plots: Daily Returns Distribution (`daily_returns_dist.png`) and Scheme Correlation Matrix (`correlation_matrix.png`).</a:t>
+              <a:t>• Expense ratio drag: Plotting fees against 3Y CAGR reveals a clear negative cost drag</a:t>
             </a:r>
           </a:p>
         </p:txBody>
@@ -5892,7 +5677,7 @@
           <a:lstStyle/>
           <a:p>
             <a:pPr>
-              <a:defRPr sz="3600" b="1">
+              <a:defRPr sz="3200" b="1">
                 <a:solidFill>
                   <a:srgbClr val="00E5FF"/>
                 </a:solidFill>
@@ -5900,7 +5685,7 @@
               </a:defRPr>
             </a:pPr>
             <a:r>
-              <a:t> Exploratory Data Analysis: Costs &amp; Cash Inflows</a:t>
+              <a:t>The Weighted Fund Scorecard</a:t>
             </a:r>
           </a:p>
         </p:txBody>
@@ -5929,25 +5714,25 @@
           <a:p>
             <a:pPr>
               <a:spcAft>
-                <a:spcPts val="800"/>
+                <a:spcPts val="2000"/>
               </a:spcAft>
-              <a:defRPr sz="1800">
-                <a:solidFill>
-                  <a:srgbClr val="DCDCDC"/>
+              <a:defRPr sz="1800" i="1">
+                <a:solidFill>
+                  <a:srgbClr val="00E5FF"/>
                 </a:solidFill>
                 <a:latin typeface="Arial"/>
               </a:defRPr>
             </a:pPr>
             <a:r>
-              <a:t>Key Points:</a:t>
+              <a:t>Dynamic performance leaderboard (Day 4)</a:t>
             </a:r>
           </a:p>
           <a:p>
             <a:pPr>
               <a:spcAft>
-                <a:spcPts val="800"/>
+                <a:spcPts val="1200"/>
               </a:spcAft>
-              <a:defRPr sz="1800">
+              <a:defRPr sz="1600">
                 <a:solidFill>
                   <a:srgbClr val="DCDCDC"/>
                 </a:solidFill>
@@ -5955,15 +5740,15 @@
               </a:defRPr>
             </a:pPr>
             <a:r>
-              <a:t>Cost Impact: Scatter plot reveals a negative relationship between high expense ratios and long-term CAGR.</a:t>
+              <a:t>• Multi-factor scoring: CAGR (30%), Sharpe (25%), Alpha (20%), Expense (15%), Drawdown (10%)</a:t>
             </a:r>
           </a:p>
           <a:p>
             <a:pPr>
               <a:spcAft>
-                <a:spcPts val="800"/>
+                <a:spcPts val="1200"/>
               </a:spcAft>
-              <a:defRPr sz="1800">
+              <a:defRPr sz="1600">
                 <a:solidFill>
                   <a:srgbClr val="DCDCDC"/>
                 </a:solidFill>
@@ -5971,15 +5756,15 @@
               </a:defRPr>
             </a:pPr>
             <a:r>
-              <a:t>SIP Expansion: Retail inflows grew steadily, with monthly SIP volumes peaking in Q4 2024.</a:t>
+              <a:t>• DSP Top 100 Equity: Ranked #1 due to strong Sharpe (1.22) and CAPM Alpha (28.8%)</a:t>
             </a:r>
           </a:p>
           <a:p>
             <a:pPr>
               <a:spcAft>
-                <a:spcPts val="800"/>
+                <a:spcPts val="1200"/>
               </a:spcAft>
-              <a:defRPr sz="1800">
+              <a:defRPr sz="1600">
                 <a:solidFill>
                   <a:srgbClr val="DCDCDC"/>
                 </a:solidFill>
@@ -5987,23 +5772,7 @@
               </a:defRPr>
             </a:pPr>
             <a:r>
-              <a:t>Asset Concentration: Large-cap funds represent the majority of total AUM.</a:t>
-            </a:r>
-          </a:p>
-          <a:p>
-            <a:pPr>
-              <a:spcAft>
-                <a:spcPts val="800"/>
-              </a:spcAft>
-              <a:defRPr sz="1800">
-                <a:solidFill>
-                  <a:srgbClr val="DCDCDC"/>
-                </a:solidFill>
-                <a:latin typeface="Arial"/>
-              </a:defRPr>
-            </a:pPr>
-            <a:r>
-              <a:t>Visual Guidelines: Left side: Cost vs. Return scatter plot. Right side: Monthly SIP volume trend chart.</a:t>
+              <a:t>• Mirae Asset Large Cap: Ranked #2 due to strong drawdown control (-17.4% max drawdown)</a:t>
             </a:r>
           </a:p>
         </p:txBody>
@@ -6057,7 +5826,7 @@
           <a:lstStyle/>
           <a:p>
             <a:pPr>
-              <a:defRPr sz="3600" b="1">
+              <a:defRPr sz="3200" b="1">
                 <a:solidFill>
                   <a:srgbClr val="00E5FF"/>
                 </a:solidFill>
@@ -6065,7 +5834,7 @@
               </a:defRPr>
             </a:pPr>
             <a:r>
-              <a:t> The Weighted Fund Scorecard</a:t>
+              <a:t>Portfolio Concentration &amp; Sector HHI</a:t>
             </a:r>
           </a:p>
         </p:txBody>
@@ -6094,25 +5863,25 @@
           <a:p>
             <a:pPr>
               <a:spcAft>
-                <a:spcPts val="800"/>
+                <a:spcPts val="2000"/>
               </a:spcAft>
-              <a:defRPr sz="1800">
-                <a:solidFill>
-                  <a:srgbClr val="DCDCDC"/>
+              <a:defRPr sz="1800" i="1">
+                <a:solidFill>
+                  <a:srgbClr val="00E5FF"/>
                 </a:solidFill>
                 <a:latin typeface="Arial"/>
               </a:defRPr>
             </a:pPr>
             <a:r>
-              <a:t>Key Points:</a:t>
+              <a:t>Measuring sector concentration (Day 6)</a:t>
             </a:r>
           </a:p>
           <a:p>
             <a:pPr>
               <a:spcAft>
-                <a:spcPts val="800"/>
+                <a:spcPts val="1200"/>
               </a:spcAft>
-              <a:defRPr sz="1800">
+              <a:defRPr sz="1600">
                 <a:solidFill>
                   <a:srgbClr val="DCDCDC"/>
                 </a:solidFill>
@@ -6120,15 +5889,15 @@
               </a:defRPr>
             </a:pPr>
             <a:r>
-              <a:t>Consolidated Ranking: Combined CAGR, Sharpe, Alpha, Expense, and Drawdown to rank all 10 funds.</a:t>
+              <a:t>• Sector HHI: Tech sectoral fund has high concentration (HHI = 7,338.00)</a:t>
             </a:r>
           </a:p>
           <a:p>
             <a:pPr>
               <a:spcAft>
-                <a:spcPts val="800"/>
+                <a:spcPts val="1200"/>
               </a:spcAft>
-              <a:defRPr sz="1800">
+              <a:defRPr sz="1600">
                 <a:solidFill>
                   <a:srgbClr val="DCDCDC"/>
                 </a:solidFill>
@@ -6136,15 +5905,15 @@
               </a:defRPr>
             </a:pPr>
             <a:r>
-              <a:t>DSP Top 100 Equity: Ranked #1 due to strong risk-adjusted returns (Sharpe 1.22) and CAPM Alpha (28.8% annualized).</a:t>
+              <a:t>• Diversified schemes: Large-cap and flexi-cap funds maintain moderate HHIs (~1,827.16)</a:t>
             </a:r>
           </a:p>
           <a:p>
             <a:pPr>
               <a:spcAft>
-                <a:spcPts val="800"/>
+                <a:spcPts val="1200"/>
               </a:spcAft>
-              <a:defRPr sz="1800">
+              <a:defRPr sz="1600">
                 <a:solidFill>
                   <a:srgbClr val="DCDCDC"/>
                 </a:solidFill>
@@ -6152,23 +5921,7 @@
               </a:defRPr>
             </a:pPr>
             <a:r>
-              <a:t>Mirae Asset Large Cap: Ranked #2 due to low max drawdown (-17.4%).</a:t>
-            </a:r>
-          </a:p>
-          <a:p>
-            <a:pPr>
-              <a:spcAft>
-                <a:spcPts val="800"/>
-              </a:spcAft>
-              <a:defRPr sz="1800">
-                <a:solidFill>
-                  <a:srgbClr val="DCDCDC"/>
-                </a:solidFill>
-                <a:latin typeface="Arial"/>
-              </a:defRPr>
-            </a:pPr>
-            <a:r>
-              <a:t>Visual Guidelines: Performance comparison table showing CAGRs, Sharpe/Sortino ratios, CAPM metrics, and final ranks.</a:t>
+              <a:t>• Asset allocation: Diversification helps reduce sector-specific risk exposure</a:t>
             </a:r>
           </a:p>
         </p:txBody>
@@ -6222,7 +5975,7 @@
           <a:lstStyle/>
           <a:p>
             <a:pPr>
-              <a:defRPr sz="3600" b="1">
+              <a:defRPr sz="3200" b="1">
                 <a:solidFill>
                   <a:srgbClr val="00E5FF"/>
                 </a:solidFill>
@@ -6230,7 +5983,7 @@
               </a:defRPr>
             </a:pPr>
             <a:r>
-              <a:t> Portfolio Concentration &amp; Tail Risk</a:t>
+              <a:t>Downside Tail Risk (VaR &amp; CVaR)</a:t>
             </a:r>
           </a:p>
         </p:txBody>
@@ -6259,25 +6012,25 @@
           <a:p>
             <a:pPr>
               <a:spcAft>
-                <a:spcPts val="800"/>
+                <a:spcPts val="2000"/>
               </a:spcAft>
-              <a:defRPr sz="1800">
-                <a:solidFill>
-                  <a:srgbClr val="DCDCDC"/>
+              <a:defRPr sz="1800" i="1">
+                <a:solidFill>
+                  <a:srgbClr val="00E5FF"/>
                 </a:solidFill>
                 <a:latin typeface="Arial"/>
               </a:defRPr>
             </a:pPr>
             <a:r>
-              <a:t>Key Points:</a:t>
+              <a:t>Estimating tail risk thresholds</a:t>
             </a:r>
           </a:p>
           <a:p>
             <a:pPr>
               <a:spcAft>
-                <a:spcPts val="800"/>
+                <a:spcPts val="1200"/>
               </a:spcAft>
-              <a:defRPr sz="1800">
+              <a:defRPr sz="1600">
                 <a:solidFill>
                   <a:srgbClr val="DCDCDC"/>
                 </a:solidFill>
@@ -6285,15 +6038,15 @@
               </a:defRPr>
             </a:pPr>
             <a:r>
-              <a:t>Sector Concentration: The Technology Fund has a high concentration score (HHI = 7,338.00), while diversified funds show lower scores (HHI = 1,827.16).</a:t>
+              <a:t>• Value at Risk (95% VaR): Tech Fund daily VaR = 2.33% vs. Mirae Large Cap = 2.08%</a:t>
             </a:r>
           </a:p>
           <a:p>
             <a:pPr>
               <a:spcAft>
-                <a:spcPts val="800"/>
+                <a:spcPts val="1200"/>
               </a:spcAft>
-              <a:defRPr sz="1800">
+              <a:defRPr sz="1600">
                 <a:solidFill>
                   <a:srgbClr val="DCDCDC"/>
                 </a:solidFill>
@@ -6301,15 +6054,15 @@
               </a:defRPr>
             </a:pPr>
             <a:r>
-              <a:t>Tail Risk (VaR &amp; CVaR): Concentrated exposure leads to higher tail risk: Tech Fund 95% Daily VaR = 2.33% vs. Mirae Large Cap = 2.08%.</a:t>
+              <a:t>• Expected Shortfall (95% CVaR): Tech Fund daily CVaR = 3.19% vs. Mirae Large Cap = 2.76%</a:t>
             </a:r>
           </a:p>
           <a:p>
             <a:pPr>
               <a:spcAft>
-                <a:spcPts val="800"/>
+                <a:spcPts val="1200"/>
               </a:spcAft>
-              <a:defRPr sz="1800">
+              <a:defRPr sz="1600">
                 <a:solidFill>
                   <a:srgbClr val="DCDCDC"/>
                 </a:solidFill>
@@ -6317,23 +6070,7 @@
               </a:defRPr>
             </a:pPr>
             <a:r>
-              <a:t>SIP Continuity: Active accounts show high continuity (87.2%), while inactive accounts show lower continuity before churning.</a:t>
-            </a:r>
-          </a:p>
-          <a:p>
-            <a:pPr>
-              <a:spcAft>
-                <a:spcPts val="800"/>
-              </a:spcAft>
-              <a:defRPr sz="1800">
-                <a:solidFill>
-                  <a:srgbClr val="DCDCDC"/>
-                </a:solidFill>
-                <a:latin typeface="Arial"/>
-              </a:defRPr>
-            </a:pPr>
-            <a:r>
-              <a:t>Visual Guidelines: Left side: HHI concentration table. Right side: Rolling 90-day Sharpe Ratio chart (`rolling_sharpe_chart.png`).</a:t>
+              <a:t>• Tail Risk: High sector concentration directly correlates with larger tail risk losses</a:t>
             </a:r>
           </a:p>
         </p:txBody>

</xml_diff>